<commit_message>
docs: replace slide 12 in presentation deck with clean Privacy Architecture slide
</commit_message>
<xml_diff>
--- a/presentation/Drowsiness_Detection_Presentation.pptx
+++ b/presentation/Drowsiness_Detection_Presentation.pptx
@@ -3902,59 +3902,209 @@
               </a:defRPr>
             </a:pPr>
             <a:r>
-              <a:t>11. Visual Proof &amp; Screenshots</a:t>
-            </a:r>
-          </a:p>
-        </p:txBody>
-      </p:sp>
-      <p:pic>
-        <p:nvPicPr>
-          <p:cNvPr id="4" name="Picture 3" descr="drowsy_sample.jpg"/>
-          <p:cNvPicPr>
-            <a:picLocks noChangeAspect="1"/>
-          </p:cNvPicPr>
+              <a:t>11. Privacy-First Architecture &amp; System Security</a:t>
+            </a:r>
+          </a:p>
+        </p:txBody>
+      </p:sp>
+      <p:sp>
+        <p:nvSpPr>
+          <p:cNvPr id="4" name="Rounded Rectangle 3"/>
+          <p:cNvSpPr/>
           <p:nvPr/>
-        </p:nvPicPr>
-        <p:blipFill>
-          <a:blip r:embed="rId2"/>
-          <a:stretch>
-            <a:fillRect/>
-          </a:stretch>
-        </p:blipFill>
-        <p:spPr>
-          <a:xfrm>
-            <a:off x="914400" y="1645920"/>
-            <a:ext cx="4937760" cy="3703320"/>
-          </a:xfrm>
-          <a:prstGeom prst="rect">
+        </p:nvSpPr>
+        <p:spPr>
+          <a:xfrm>
+            <a:off x="731520" y="1645920"/>
+            <a:ext cx="5120640" cy="4389120"/>
+          </a:xfrm>
+          <a:prstGeom prst="roundRect">
             <a:avLst/>
           </a:prstGeom>
-        </p:spPr>
-      </p:pic>
-      <p:pic>
-        <p:nvPicPr>
-          <p:cNvPr id="5" name="Picture 4" descr="yawn_sample.jpg"/>
-          <p:cNvPicPr>
-            <a:picLocks noChangeAspect="1"/>
-          </p:cNvPicPr>
+          <a:solidFill>
+            <a:srgbClr val="1E293B"/>
+          </a:solidFill>
+          <a:ln>
+            <a:solidFill>
+              <a:srgbClr val="38BDF8"/>
+            </a:solidFill>
+          </a:ln>
+        </p:spPr>
+        <p:style>
+          <a:lnRef idx="1">
+            <a:schemeClr val="accent1"/>
+          </a:lnRef>
+          <a:fillRef idx="3">
+            <a:schemeClr val="accent1"/>
+          </a:fillRef>
+          <a:effectRef idx="2">
+            <a:schemeClr val="accent1"/>
+          </a:effectRef>
+          <a:fontRef idx="minor">
+            <a:schemeClr val="lt1"/>
+          </a:fontRef>
+        </p:style>
+        <p:txBody>
+          <a:bodyPr rtlCol="0" anchor="ctr" wrap="square"/>
+          <a:lstStyle/>
+          <a:p>
+            <a:pPr algn="ctr">
+              <a:defRPr sz="1800" b="1">
+                <a:solidFill>
+                  <a:srgbClr val="38BDF8"/>
+                </a:solidFill>
+              </a:defRPr>
+            </a:pPr>
+            <a:r>
+              <a:t>🔒 Privacy-Preserving Execution</a:t>
+            </a:r>
+          </a:p>
+          <a:p>
+            <a:pPr>
+              <a:spcBef>
+                <a:spcPts val="1200"/>
+              </a:spcBef>
+              <a:defRPr sz="1300">
+                <a:solidFill>
+                  <a:srgbClr val="F8FAFC"/>
+                </a:solidFill>
+              </a:defRPr>
+            </a:pPr>
+            <a:r>
+              <a:t>• Local Edge Execution: Camera feeds are processed entirely in memory; no video streams leave the local device.</a:t>
+            </a:r>
+          </a:p>
+          <a:p>
+            <a:pPr>
+              <a:spcBef>
+                <a:spcPts val="1200"/>
+              </a:spcBef>
+              <a:defRPr sz="1300">
+                <a:solidFill>
+                  <a:srgbClr val="F8FAFC"/>
+                </a:solidFill>
+              </a:defRPr>
+            </a:pPr>
+            <a:r>
+              <a:t>• Zero Cloud Streaming: No facial video or biometric data is stored remotely.</a:t>
+            </a:r>
+          </a:p>
+          <a:p>
+            <a:pPr>
+              <a:spcBef>
+                <a:spcPts val="1200"/>
+              </a:spcBef>
+              <a:defRPr sz="1300">
+                <a:solidFill>
+                  <a:srgbClr val="F8FAFC"/>
+                </a:solidFill>
+              </a:defRPr>
+            </a:pPr>
+            <a:r>
+              <a:t>• Ignored Log Files: Local event logs are strictly excluded via .gitignore rules to prevent accidental repo uploads.</a:t>
+            </a:r>
+          </a:p>
+        </p:txBody>
+      </p:sp>
+      <p:sp>
+        <p:nvSpPr>
+          <p:cNvPr id="5" name="Rounded Rectangle 4"/>
+          <p:cNvSpPr/>
           <p:nvPr/>
-        </p:nvPicPr>
-        <p:blipFill>
-          <a:blip r:embed="rId3"/>
-          <a:stretch>
-            <a:fillRect/>
-          </a:stretch>
-        </p:blipFill>
+        </p:nvSpPr>
         <p:spPr>
           <a:xfrm>
             <a:off x="6309360" y="1645920"/>
-            <a:ext cx="4937760" cy="3703320"/>
-          </a:xfrm>
-          <a:prstGeom prst="rect">
+            <a:ext cx="5120640" cy="4389120"/>
+          </a:xfrm>
+          <a:prstGeom prst="roundRect">
             <a:avLst/>
           </a:prstGeom>
-        </p:spPr>
-      </p:pic>
+          <a:solidFill>
+            <a:srgbClr val="1E293B"/>
+          </a:solidFill>
+          <a:ln>
+            <a:solidFill>
+              <a:srgbClr val="C084FC"/>
+            </a:solidFill>
+          </a:ln>
+        </p:spPr>
+        <p:style>
+          <a:lnRef idx="1">
+            <a:schemeClr val="accent1"/>
+          </a:lnRef>
+          <a:fillRef idx="3">
+            <a:schemeClr val="accent1"/>
+          </a:fillRef>
+          <a:effectRef idx="2">
+            <a:schemeClr val="accent1"/>
+          </a:effectRef>
+          <a:fontRef idx="minor">
+            <a:schemeClr val="lt1"/>
+          </a:fontRef>
+        </p:style>
+        <p:txBody>
+          <a:bodyPr rtlCol="0" anchor="ctr" wrap="square"/>
+          <a:lstStyle/>
+          <a:p>
+            <a:pPr algn="ctr">
+              <a:defRPr sz="1800" b="1">
+                <a:solidFill>
+                  <a:srgbClr val="C084FC"/>
+                </a:solidFill>
+              </a:defRPr>
+            </a:pPr>
+            <a:r>
+              <a:t>🎯 Vector Geometry Tracking</a:t>
+            </a:r>
+          </a:p>
+          <a:p>
+            <a:pPr>
+              <a:spcBef>
+                <a:spcPts val="1200"/>
+              </a:spcBef>
+              <a:defRPr sz="1300">
+                <a:solidFill>
+                  <a:srgbClr val="F8FAFC"/>
+                </a:solidFill>
+              </a:defRPr>
+            </a:pPr>
+            <a:r>
+              <a:t>• 468 Landmark Mesh: Extracts precise 3D coordinate vectors (x, y, z) per frame.</a:t>
+            </a:r>
+          </a:p>
+          <a:p>
+            <a:pPr>
+              <a:spcBef>
+                <a:spcPts val="1200"/>
+              </a:spcBef>
+              <a:defRPr sz="1300">
+                <a:solidFill>
+                  <a:srgbClr val="F8FAFC"/>
+                </a:solidFill>
+              </a:defRPr>
+            </a:pPr>
+            <a:r>
+              <a:t>• Synthetic Metric Telemetry: Converts raw pixels into normalized aspect ratio scalars (EAR &amp; MAR).</a:t>
+            </a:r>
+          </a:p>
+          <a:p>
+            <a:pPr>
+              <a:spcBef>
+                <a:spcPts val="1200"/>
+              </a:spcBef>
+              <a:defRPr sz="1300">
+                <a:solidFill>
+                  <a:srgbClr val="F8FAFC"/>
+                </a:solidFill>
+              </a:defRPr>
+            </a:pPr>
+            <a:r>
+              <a:t>• Non-Intrusive Sensing: Eliminates physical wearable hardware requirements.</a:t>
+            </a:r>
+          </a:p>
+        </p:txBody>
+      </p:sp>
     </p:spTree>
   </p:cSld>
   <p:clrMapOvr>
@@ -5380,7 +5530,7 @@
               </a:defRPr>
             </a:pPr>
             <a:r>
-              <a:t>✔  Trigger immediate audio alarms via Pygame mixer and capture timestamped screenshot evidence.</a:t>
+              <a:t>✔  Trigger immediate audio alarms via Pygame mixer and log event timestamps locally.</a:t>
             </a:r>
           </a:p>
         </p:txBody>

</xml_diff>